<commit_message>
/mds and presentations fixes
</commit_message>
<xml_diff>
--- a/presentations/Grunitech_Project_LLM_and_fine-tuning_consolidated.pptx
+++ b/presentations/Grunitech_Project_LLM_and_fine-tuning_consolidated.pptx
@@ -18,6 +18,7 @@
     <p:sldId id="263" r:id="rId14"/>
     <p:sldId id="264" r:id="rId15"/>
     <p:sldId id="277" r:id="rId28"/>
+    <p:sldId id="289" r:id="rId40"/>
     <p:sldId id="265" r:id="rId16"/>
     <p:sldId id="266" r:id="rId17"/>
     <p:sldId id="267" r:id="rId18"/>
@@ -3196,6 +3197,112 @@
           <a:p>
             <a:r>
               <a:t>Happy to take questions.</a:t>
+            </a:r>
+          </a:p>
+        </p:txBody>
+      </p:sp>
+    </p:spTree>
+  </p:cSld>
+  <p:clrMapOvr>
+    <a:masterClrMapping/>
+  </p:clrMapOvr>
+</p:notes>
+</file>
+
+<file path=ppt/notesSlides/notesSlide34.xml><?xml version="1.0" encoding="utf-8"?>
+<p:notes xmlns:a="http://schemas.openxmlformats.org/drawingml/2006/main" xmlns:p="http://schemas.openxmlformats.org/presentationml/2006/main" xmlns:r="http://schemas.openxmlformats.org/officeDocument/2006/relationships">
+  <p:cSld>
+    <p:spTree>
+      <p:nvGrpSpPr>
+        <p:cNvPr id="1" name=""/>
+        <p:cNvGrpSpPr/>
+        <p:nvPr/>
+      </p:nvGrpSpPr>
+      <p:grpSpPr>
+        <a:xfrm>
+          <a:off x="0" y="0"/>
+          <a:ext cx="0" cy="0"/>
+          <a:chOff x="0" y="0"/>
+          <a:chExt cx="0" cy="0"/>
+        </a:xfrm>
+      </p:grpSpPr>
+      <p:sp>
+        <p:nvSpPr>
+          <p:cNvPr id="2" name="Slide Image Placeholder 1"/>
+          <p:cNvSpPr>
+            <a:spLocks noGrp="1"/>
+          </p:cNvSpPr>
+          <p:nvPr>
+            <p:ph type="sldImg" idx="2"/>
+          </p:nvPr>
+        </p:nvSpPr>
+        <p:spPr/>
+      </p:sp>
+      <p:sp>
+        <p:nvSpPr>
+          <p:cNvPr id="3" name="Notes Placeholder 2"/>
+          <p:cNvSpPr>
+            <a:spLocks noGrp="1"/>
+          </p:cNvSpPr>
+          <p:nvPr>
+            <p:ph type="body" idx="1"/>
+          </p:nvPr>
+        </p:nvSpPr>
+        <p:spPr/>
+        <p:txBody>
+          <a:bodyPr/>
+          <a:lstStyle/>
+          <a:p>
+            <a:r>
+              <a:t>One more data check before any model: is 90 minutes even the right thing to predict?</a:t>
+            </a:r>
+          </a:p>
+          <a:p/>
+          <a:p>
+            <a:r>
+              <a:t>We bucketed the realised move into Loss, Neutral and Gain at a half-percent threshold.</a:t>
+            </a:r>
+          </a:p>
+          <a:p>
+            <a:r>
+              <a:t>The Neutral column dominates every row -- 52% of all articles are followed by a move</a:t>
+            </a:r>
+          </a:p>
+          <a:p>
+            <a:r>
+              <a:t>smaller than half a percent. More than half the corpus is "nothing happened", which is</a:t>
+            </a:r>
+          </a:p>
+          <a:p>
+            <a:r>
+              <a:t>a hard thing to regress against for reasons that have nothing to do with the model.</a:t>
+            </a:r>
+          </a:p>
+          <a:p/>
+          <a:p>
+            <a:r>
+              <a:t>And of the articles that did move, the split is 50.2% down against 49.8% up. The loss</a:t>
+            </a:r>
+          </a:p>
+          <a:p>
+            <a:r>
+              <a:t>share wanders between 47% and 55% across the rows with no ordering by sentiment --</a:t>
+            </a:r>
+          </a:p>
+          <a:p>
+            <a:r>
+              <a:t>the strongly-negative row is 54.5% losses, the merely-negative row is 46.8%.</a:t>
+            </a:r>
+          </a:p>
+          <a:p/>
+          <a:p>
+            <a:r>
+              <a:t>We have the script to extend this to 24-hour and 7-day windows; those columns are not</a:t>
+            </a:r>
+          </a:p>
+          <a:p>
+            <a:r>
+              <a:t>populated yet. Longer windows do move more -- whether they move predictably is open.</a:t>
             </a:r>
           </a:p>
         </p:txBody>
@@ -8557,6 +8664,389 @@
 </file>
 
 <file path=ppt/slides/slide10.xml><?xml version="1.0" encoding="utf-8"?>
+<p:sld xmlns:a="http://schemas.openxmlformats.org/drawingml/2006/main" xmlns:p="http://schemas.openxmlformats.org/presentationml/2006/main" xmlns:r="http://schemas.openxmlformats.org/officeDocument/2006/relationships">
+  <p:cSld>
+    <p:spTree>
+      <p:nvGrpSpPr>
+        <p:cNvPr id="1" name=""/>
+        <p:cNvGrpSpPr/>
+        <p:nvPr/>
+      </p:nvGrpSpPr>
+      <p:grpSpPr/>
+      <p:sp>
+        <p:nvSpPr>
+          <p:cNvPr id="2" name="Title 1"/>
+          <p:cNvSpPr>
+            <a:spLocks noGrp="1"/>
+          </p:cNvSpPr>
+          <p:nvPr>
+            <p:ph type="title"/>
+          </p:nvPr>
+        </p:nvSpPr>
+        <p:spPr/>
+        <p:txBody>
+          <a:bodyPr/>
+          <a:lstStyle/>
+          <a:p>
+            <a:r>
+              <a:t>Sentiment vs. what happened next</a:t>
+            </a:r>
+          </a:p>
+        </p:txBody>
+      </p:sp>
+      <p:graphicFrame>
+        <p:nvGraphicFramePr>
+          <p:cNvPr id="3" name="Table 2"/>
+          <p:cNvGraphicFramePr>
+            <a:graphicFrameLocks noGrp="1"/>
+          </p:cNvGraphicFramePr>
+          <p:nvPr/>
+        </p:nvGraphicFramePr>
+        <p:xfrm>
+          <a:off x="640080" y="1188720"/>
+          <a:ext cx="7863840" cy="1645919"/>
+        </p:xfrm>
+        <a:graphic>
+          <a:graphicData uri="http://schemas.openxmlformats.org/drawingml/2006/table">
+            <a:tbl>
+              <a:tblPr firstRow="1" bandRow="1">
+                <a:tableStyleId>{5C22544A-7EE6-4342-B048-85BDC9FD1C3A}</a:tableStyleId>
+              </a:tblPr>
+              <a:tblGrid>
+                <a:gridCol w="3108960"/>
+                <a:gridCol w="2377440"/>
+                <a:gridCol w="2377440"/>
+              </a:tblGrid>
+              <a:tr h="274319">
+                <a:tc>
+                  <a:txBody>
+                    <a:bodyPr/>
+                    <a:lstStyle/>
+                    <a:p>
+                      <a:pPr>
+                        <a:defRPr sz="1200" b="1"/>
+                      </a:pPr>
+                      <a:r>
+                        <a:t>LLM sentiment</a:t>
+                      </a:r>
+                    </a:p>
+                  </a:txBody>
+                  <a:tcPr/>
+                </a:tc>
+                <a:tc>
+                  <a:txBody>
+                    <a:bodyPr/>
+                    <a:lstStyle/>
+                    <a:p>
+                      <a:pPr>
+                        <a:defRPr sz="1200" b="1"/>
+                      </a:pPr>
+                      <a:r>
+                        <a:t>next move DOWN</a:t>
+                      </a:r>
+                    </a:p>
+                  </a:txBody>
+                  <a:tcPr/>
+                </a:tc>
+                <a:tc>
+                  <a:txBody>
+                    <a:bodyPr/>
+                    <a:lstStyle/>
+                    <a:p>
+                      <a:pPr>
+                        <a:defRPr sz="1200" b="1"/>
+                      </a:pPr>
+                      <a:r>
+                        <a:t>next move UP</a:t>
+                      </a:r>
+                    </a:p>
+                  </a:txBody>
+                  <a:tcPr/>
+                </a:tc>
+              </a:tr>
+              <a:tr h="274319">
+                <a:tc>
+                  <a:txBody>
+                    <a:bodyPr/>
+                    <a:lstStyle/>
+                    <a:p>
+                      <a:pPr>
+                        <a:defRPr sz="1200" b="0"/>
+                      </a:pPr>
+                      <a:r>
+                        <a:t>Strongly negative</a:t>
+                      </a:r>
+                    </a:p>
+                  </a:txBody>
+                  <a:tcPr/>
+                </a:tc>
+                <a:tc>
+                  <a:txBody>
+                    <a:bodyPr/>
+                    <a:lstStyle/>
+                    <a:p>
+                      <a:pPr>
+                        <a:defRPr sz="1200" b="0"/>
+                      </a:pPr>
+                      <a:r>
+                        <a:t>50.80%</a:t>
+                      </a:r>
+                    </a:p>
+                  </a:txBody>
+                  <a:tcPr/>
+                </a:tc>
+                <a:tc>
+                  <a:txBody>
+                    <a:bodyPr/>
+                    <a:lstStyle/>
+                    <a:p>
+                      <a:pPr>
+                        <a:defRPr sz="1200" b="0"/>
+                      </a:pPr>
+                      <a:r>
+                        <a:t>49.20%</a:t>
+                      </a:r>
+                    </a:p>
+                  </a:txBody>
+                  <a:tcPr/>
+                </a:tc>
+              </a:tr>
+              <a:tr h="274319">
+                <a:tc>
+                  <a:txBody>
+                    <a:bodyPr/>
+                    <a:lstStyle/>
+                    <a:p>
+                      <a:pPr>
+                        <a:defRPr sz="1200" b="0"/>
+                      </a:pPr>
+                      <a:r>
+                        <a:t>Negative</a:t>
+                      </a:r>
+                    </a:p>
+                  </a:txBody>
+                  <a:tcPr/>
+                </a:tc>
+                <a:tc>
+                  <a:txBody>
+                    <a:bodyPr/>
+                    <a:lstStyle/>
+                    <a:p>
+                      <a:pPr>
+                        <a:defRPr sz="1200" b="0"/>
+                      </a:pPr>
+                      <a:r>
+                        <a:t>49.82%</a:t>
+                      </a:r>
+                    </a:p>
+                  </a:txBody>
+                  <a:tcPr/>
+                </a:tc>
+                <a:tc>
+                  <a:txBody>
+                    <a:bodyPr/>
+                    <a:lstStyle/>
+                    <a:p>
+                      <a:pPr>
+                        <a:defRPr sz="1200" b="0"/>
+                      </a:pPr>
+                      <a:r>
+                        <a:t>50.18%</a:t>
+                      </a:r>
+                    </a:p>
+                  </a:txBody>
+                  <a:tcPr/>
+                </a:tc>
+              </a:tr>
+              <a:tr h="274319">
+                <a:tc>
+                  <a:txBody>
+                    <a:bodyPr/>
+                    <a:lstStyle/>
+                    <a:p>
+                      <a:pPr>
+                        <a:defRPr sz="1200" b="0"/>
+                      </a:pPr>
+                      <a:r>
+                        <a:t>Neutral</a:t>
+                      </a:r>
+                    </a:p>
+                  </a:txBody>
+                  <a:tcPr/>
+                </a:tc>
+                <a:tc>
+                  <a:txBody>
+                    <a:bodyPr/>
+                    <a:lstStyle/>
+                    <a:p>
+                      <a:pPr>
+                        <a:defRPr sz="1200" b="0"/>
+                      </a:pPr>
+                      <a:r>
+                        <a:t>51.14%</a:t>
+                      </a:r>
+                    </a:p>
+                  </a:txBody>
+                  <a:tcPr/>
+                </a:tc>
+                <a:tc>
+                  <a:txBody>
+                    <a:bodyPr/>
+                    <a:lstStyle/>
+                    <a:p>
+                      <a:pPr>
+                        <a:defRPr sz="1200" b="0"/>
+                      </a:pPr>
+                      <a:r>
+                        <a:t>48.86%</a:t>
+                      </a:r>
+                    </a:p>
+                  </a:txBody>
+                  <a:tcPr/>
+                </a:tc>
+              </a:tr>
+              <a:tr h="274319">
+                <a:tc>
+                  <a:txBody>
+                    <a:bodyPr/>
+                    <a:lstStyle/>
+                    <a:p>
+                      <a:pPr>
+                        <a:defRPr sz="1200" b="0"/>
+                      </a:pPr>
+                      <a:r>
+                        <a:t>Positive</a:t>
+                      </a:r>
+                    </a:p>
+                  </a:txBody>
+                  <a:tcPr/>
+                </a:tc>
+                <a:tc>
+                  <a:txBody>
+                    <a:bodyPr/>
+                    <a:lstStyle/>
+                    <a:p>
+                      <a:pPr>
+                        <a:defRPr sz="1200" b="0"/>
+                      </a:pPr>
+                      <a:r>
+                        <a:t>49.76%</a:t>
+                      </a:r>
+                    </a:p>
+                  </a:txBody>
+                  <a:tcPr/>
+                </a:tc>
+                <a:tc>
+                  <a:txBody>
+                    <a:bodyPr/>
+                    <a:lstStyle/>
+                    <a:p>
+                      <a:pPr>
+                        <a:defRPr sz="1200" b="0"/>
+                      </a:pPr>
+                      <a:r>
+                        <a:t>50.24%</a:t>
+                      </a:r>
+                    </a:p>
+                  </a:txBody>
+                  <a:tcPr/>
+                </a:tc>
+              </a:tr>
+              <a:tr h="274324">
+                <a:tc>
+                  <a:txBody>
+                    <a:bodyPr/>
+                    <a:lstStyle/>
+                    <a:p>
+                      <a:pPr>
+                        <a:defRPr sz="1200" b="0"/>
+                      </a:pPr>
+                      <a:r>
+                        <a:t>Strongly positive</a:t>
+                      </a:r>
+                    </a:p>
+                  </a:txBody>
+                  <a:tcPr/>
+                </a:tc>
+                <a:tc>
+                  <a:txBody>
+                    <a:bodyPr/>
+                    <a:lstStyle/>
+                    <a:p>
+                      <a:pPr>
+                        <a:defRPr sz="1200" b="0"/>
+                      </a:pPr>
+                      <a:r>
+                        <a:t>50.14%</a:t>
+                      </a:r>
+                    </a:p>
+                  </a:txBody>
+                  <a:tcPr/>
+                </a:tc>
+                <a:tc>
+                  <a:txBody>
+                    <a:bodyPr/>
+                    <a:lstStyle/>
+                    <a:p>
+                      <a:pPr>
+                        <a:defRPr sz="1200" b="0"/>
+                      </a:pPr>
+                      <a:r>
+                        <a:t>49.86%</a:t>
+                      </a:r>
+                    </a:p>
+                  </a:txBody>
+                  <a:tcPr/>
+                </a:tc>
+              </a:tr>
+            </a:tbl>
+          </a:graphicData>
+        </a:graphic>
+      </p:graphicFrame>
+      <p:sp>
+        <p:nvSpPr>
+          <p:cNvPr id="4" name="TextBox 3"/>
+          <p:cNvSpPr txBox="1"/>
+          <p:nvPr/>
+        </p:nvSpPr>
+        <p:spPr>
+          <a:xfrm>
+            <a:off x="310896" y="4023360"/>
+            <a:ext cx="8522208" cy="548640"/>
+          </a:xfrm>
+          <a:prstGeom prst="rect">
+            <a:avLst/>
+          </a:prstGeom>
+          <a:noFill/>
+        </p:spPr>
+        <p:txBody>
+          <a:bodyPr wrap="square">
+            <a:spAutoFit/>
+          </a:bodyPr>
+          <a:lstStyle/>
+          <a:p>
+            <a:pPr algn="ctr">
+              <a:defRPr sz="1400" b="1">
+                <a:solidFill>
+                  <a:srgbClr val="C0392B"/>
+                </a:solidFill>
+              </a:defRPr>
+            </a:pPr>
+            <a:r>
+              <a:t>Every sentiment class is a coin flip — a property of the data, not of any model.</a:t>
+            </a:r>
+          </a:p>
+        </p:txBody>
+      </p:sp>
+    </p:spTree>
+  </p:cSld>
+  <p:clrMapOvr>
+    <a:masterClrMapping/>
+  </p:clrMapOvr>
+</p:sld>
+</file>
+
+<file path=ppt/slides/slide11.xml><?xml version="1.0" encoding="utf-8"?>
 <p:sld xmlns:a="http://schemas.openxmlformats.org/drawingml/2006/main" xmlns:r="http://schemas.openxmlformats.org/officeDocument/2006/relationships" xmlns:mc="http://schemas.openxmlformats.org/markup-compatibility/2006" xmlns:mv="urn:schemas-microsoft-com:mac:vml" xmlns:p="http://schemas.openxmlformats.org/presentationml/2006/main" xmlns:c="http://schemas.openxmlformats.org/drawingml/2006/chart" xmlns:dgm="http://schemas.openxmlformats.org/drawingml/2006/diagram" xmlns:o="urn:schemas-microsoft-com:office:office" xmlns:v="urn:schemas-microsoft-com:vml" xmlns:pvml="urn:schemas-microsoft-com:office:powerpoint" xmlns:com="http://schemas.openxmlformats.org/drawingml/2006/compatibility" xmlns:p14="http://schemas.microsoft.com/office/powerpoint/2010/main" xmlns:p15="http://schemas.microsoft.com/office/powerpoint/2012/main" xmlns:ahyp="http://schemas.microsoft.com/office/drawing/2018/hyperlinkcolor">
   <p:cSld>
     <p:spTree>
@@ -8660,7 +9150,7 @@
 </p:sld>
 </file>
 
-<file path=ppt/slides/slide11.xml><?xml version="1.0" encoding="utf-8"?>
+<file path=ppt/slides/slide12.xml><?xml version="1.0" encoding="utf-8"?>
 <p:sld xmlns:a="http://schemas.openxmlformats.org/drawingml/2006/main" xmlns:r="http://schemas.openxmlformats.org/officeDocument/2006/relationships" xmlns:mc="http://schemas.openxmlformats.org/markup-compatibility/2006" xmlns:mv="urn:schemas-microsoft-com:mac:vml" xmlns:p="http://schemas.openxmlformats.org/presentationml/2006/main" xmlns:c="http://schemas.openxmlformats.org/drawingml/2006/chart" xmlns:dgm="http://schemas.openxmlformats.org/drawingml/2006/diagram" xmlns:o="urn:schemas-microsoft-com:office:office" xmlns:v="urn:schemas-microsoft-com:vml" xmlns:pvml="urn:schemas-microsoft-com:office:powerpoint" xmlns:com="http://schemas.openxmlformats.org/drawingml/2006/compatibility" xmlns:p14="http://schemas.microsoft.com/office/powerpoint/2010/main" xmlns:p15="http://schemas.microsoft.com/office/powerpoint/2012/main" xmlns:ahyp="http://schemas.microsoft.com/office/drawing/2018/hyperlinkcolor">
   <p:cSld>
     <p:spTree>
@@ -8812,7 +9302,7 @@
 </p:sld>
 </file>
 
-<file path=ppt/slides/slide12.xml><?xml version="1.0" encoding="utf-8"?>
+<file path=ppt/slides/slide13.xml><?xml version="1.0" encoding="utf-8"?>
 <p:sld xmlns:a="http://schemas.openxmlformats.org/drawingml/2006/main" xmlns:r="http://schemas.openxmlformats.org/officeDocument/2006/relationships" xmlns:mc="http://schemas.openxmlformats.org/markup-compatibility/2006" xmlns:mv="urn:schemas-microsoft-com:mac:vml" xmlns:p="http://schemas.openxmlformats.org/presentationml/2006/main" xmlns:c="http://schemas.openxmlformats.org/drawingml/2006/chart" xmlns:dgm="http://schemas.openxmlformats.org/drawingml/2006/diagram" xmlns:o="urn:schemas-microsoft-com:office:office" xmlns:v="urn:schemas-microsoft-com:vml" xmlns:pvml="urn:schemas-microsoft-com:office:powerpoint" xmlns:com="http://schemas.openxmlformats.org/drawingml/2006/compatibility" xmlns:p14="http://schemas.microsoft.com/office/powerpoint/2010/main" xmlns:p15="http://schemas.microsoft.com/office/powerpoint/2012/main" xmlns:ahyp="http://schemas.microsoft.com/office/drawing/2018/hyperlinkcolor">
   <p:cSld>
     <p:spTree>
@@ -9504,7 +9994,7 @@
 </p:sld>
 </file>
 
-<file path=ppt/slides/slide13.xml><?xml version="1.0" encoding="utf-8"?>
+<file path=ppt/slides/slide14.xml><?xml version="1.0" encoding="utf-8"?>
 <p:sld xmlns:a="http://schemas.openxmlformats.org/drawingml/2006/main" xmlns:r="http://schemas.openxmlformats.org/officeDocument/2006/relationships" xmlns:mc="http://schemas.openxmlformats.org/markup-compatibility/2006" xmlns:mv="urn:schemas-microsoft-com:mac:vml" xmlns:p="http://schemas.openxmlformats.org/presentationml/2006/main" xmlns:c="http://schemas.openxmlformats.org/drawingml/2006/chart" xmlns:dgm="http://schemas.openxmlformats.org/drawingml/2006/diagram" xmlns:o="urn:schemas-microsoft-com:office:office" xmlns:v="urn:schemas-microsoft-com:vml" xmlns:pvml="urn:schemas-microsoft-com:office:powerpoint" xmlns:com="http://schemas.openxmlformats.org/drawingml/2006/compatibility" xmlns:p14="http://schemas.microsoft.com/office/powerpoint/2010/main" xmlns:p15="http://schemas.microsoft.com/office/powerpoint/2012/main" xmlns:ahyp="http://schemas.microsoft.com/office/drawing/2018/hyperlinkcolor">
   <p:cSld>
     <p:spTree>
@@ -9988,7 +10478,7 @@
 </p:sld>
 </file>
 
-<file path=ppt/slides/slide14.xml><?xml version="1.0" encoding="utf-8"?>
+<file path=ppt/slides/slide15.xml><?xml version="1.0" encoding="utf-8"?>
 <p:sld xmlns:a="http://schemas.openxmlformats.org/drawingml/2006/main" xmlns:r="http://schemas.openxmlformats.org/officeDocument/2006/relationships" xmlns:mc="http://schemas.openxmlformats.org/markup-compatibility/2006" xmlns:mv="urn:schemas-microsoft-com:mac:vml" xmlns:p="http://schemas.openxmlformats.org/presentationml/2006/main" xmlns:c="http://schemas.openxmlformats.org/drawingml/2006/chart" xmlns:dgm="http://schemas.openxmlformats.org/drawingml/2006/diagram" xmlns:o="urn:schemas-microsoft-com:office:office" xmlns:v="urn:schemas-microsoft-com:vml" xmlns:pvml="urn:schemas-microsoft-com:office:powerpoint" xmlns:com="http://schemas.openxmlformats.org/drawingml/2006/compatibility" xmlns:p14="http://schemas.microsoft.com/office/powerpoint/2010/main" xmlns:p15="http://schemas.microsoft.com/office/powerpoint/2012/main" xmlns:ahyp="http://schemas.microsoft.com/office/drawing/2018/hyperlinkcolor">
   <p:cSld>
     <p:spTree>
@@ -11912,7 +12402,7 @@
 </p:sld>
 </file>
 
-<file path=ppt/slides/slide15.xml><?xml version="1.0" encoding="utf-8"?>
+<file path=ppt/slides/slide16.xml><?xml version="1.0" encoding="utf-8"?>
 <p:sld xmlns:a="http://schemas.openxmlformats.org/drawingml/2006/main" xmlns:r="http://schemas.openxmlformats.org/officeDocument/2006/relationships" xmlns:mc="http://schemas.openxmlformats.org/markup-compatibility/2006" xmlns:mv="urn:schemas-microsoft-com:mac:vml" xmlns:p="http://schemas.openxmlformats.org/presentationml/2006/main" xmlns:c="http://schemas.openxmlformats.org/drawingml/2006/chart" xmlns:dgm="http://schemas.openxmlformats.org/drawingml/2006/diagram" xmlns:o="urn:schemas-microsoft-com:office:office" xmlns:v="urn:schemas-microsoft-com:vml" xmlns:pvml="urn:schemas-microsoft-com:office:powerpoint" xmlns:com="http://schemas.openxmlformats.org/drawingml/2006/compatibility" xmlns:p14="http://schemas.microsoft.com/office/powerpoint/2010/main" xmlns:p15="http://schemas.microsoft.com/office/powerpoint/2012/main" xmlns:ahyp="http://schemas.microsoft.com/office/drawing/2018/hyperlinkcolor">
   <p:cSld>
     <p:spTree>
@@ -12016,7 +12506,7 @@
 </p:sld>
 </file>
 
-<file path=ppt/slides/slide16.xml><?xml version="1.0" encoding="utf-8"?>
+<file path=ppt/slides/slide17.xml><?xml version="1.0" encoding="utf-8"?>
 <p:sld xmlns:a="http://schemas.openxmlformats.org/drawingml/2006/main" xmlns:r="http://schemas.openxmlformats.org/officeDocument/2006/relationships" xmlns:mc="http://schemas.openxmlformats.org/markup-compatibility/2006" xmlns:mv="urn:schemas-microsoft-com:mac:vml" xmlns:p="http://schemas.openxmlformats.org/presentationml/2006/main" xmlns:c="http://schemas.openxmlformats.org/drawingml/2006/chart" xmlns:dgm="http://schemas.openxmlformats.org/drawingml/2006/diagram" xmlns:o="urn:schemas-microsoft-com:office:office" xmlns:v="urn:schemas-microsoft-com:vml" xmlns:pvml="urn:schemas-microsoft-com:office:powerpoint" xmlns:com="http://schemas.openxmlformats.org/drawingml/2006/compatibility" xmlns:p14="http://schemas.microsoft.com/office/powerpoint/2010/main" xmlns:p15="http://schemas.microsoft.com/office/powerpoint/2012/main" xmlns:ahyp="http://schemas.microsoft.com/office/drawing/2018/hyperlinkcolor">
   <p:cSld>
     <p:spTree>
@@ -12197,7 +12687,7 @@
 </p:sld>
 </file>
 
-<file path=ppt/slides/slide17.xml><?xml version="1.0" encoding="utf-8"?>
+<file path=ppt/slides/slide18.xml><?xml version="1.0" encoding="utf-8"?>
 <p:sld xmlns:a="http://schemas.openxmlformats.org/drawingml/2006/main" xmlns:r="http://schemas.openxmlformats.org/officeDocument/2006/relationships" xmlns:mc="http://schemas.openxmlformats.org/markup-compatibility/2006" xmlns:mv="urn:schemas-microsoft-com:mac:vml" xmlns:p="http://schemas.openxmlformats.org/presentationml/2006/main" xmlns:c="http://schemas.openxmlformats.org/drawingml/2006/chart" xmlns:dgm="http://schemas.openxmlformats.org/drawingml/2006/diagram" xmlns:o="urn:schemas-microsoft-com:office:office" xmlns:v="urn:schemas-microsoft-com:vml" xmlns:pvml="urn:schemas-microsoft-com:office:powerpoint" xmlns:com="http://schemas.openxmlformats.org/drawingml/2006/compatibility" xmlns:p14="http://schemas.microsoft.com/office/powerpoint/2010/main" xmlns:p15="http://schemas.microsoft.com/office/powerpoint/2012/main" xmlns:ahyp="http://schemas.microsoft.com/office/drawing/2018/hyperlinkcolor">
   <p:cSld>
     <p:spTree>
@@ -12290,7 +12780,7 @@
 </p:sld>
 </file>
 
-<file path=ppt/slides/slide18.xml><?xml version="1.0" encoding="utf-8"?>
+<file path=ppt/slides/slide19.xml><?xml version="1.0" encoding="utf-8"?>
 <p:sld xmlns:a="http://schemas.openxmlformats.org/drawingml/2006/main" xmlns:r="http://schemas.openxmlformats.org/officeDocument/2006/relationships" xmlns:mc="http://schemas.openxmlformats.org/markup-compatibility/2006" xmlns:mv="urn:schemas-microsoft-com:mac:vml" xmlns:p="http://schemas.openxmlformats.org/presentationml/2006/main" xmlns:c="http://schemas.openxmlformats.org/drawingml/2006/chart" xmlns:dgm="http://schemas.openxmlformats.org/drawingml/2006/diagram" xmlns:o="urn:schemas-microsoft-com:office:office" xmlns:v="urn:schemas-microsoft-com:vml" xmlns:pvml="urn:schemas-microsoft-com:office:powerpoint" xmlns:com="http://schemas.openxmlformats.org/drawingml/2006/compatibility" xmlns:p14="http://schemas.microsoft.com/office/powerpoint/2010/main" xmlns:p15="http://schemas.microsoft.com/office/powerpoint/2012/main" xmlns:ahyp="http://schemas.microsoft.com/office/drawing/2018/hyperlinkcolor">
   <p:cSld>
     <p:spTree>
@@ -12369,99 +12859,6 @@
           <a:xfrm>
             <a:off x="152400" y="1170125"/>
             <a:ext cx="8839201" cy="2542184"/>
-          </a:xfrm>
-          <a:prstGeom prst="rect">
-            <a:avLst/>
-          </a:prstGeom>
-          <a:noFill/>
-          <a:ln>
-            <a:noFill/>
-          </a:ln>
-        </p:spPr>
-      </p:pic>
-    </p:spTree>
-  </p:cSld>
-  <p:clrMapOvr>
-    <a:masterClrMapping/>
-  </p:clrMapOvr>
-</p:sld>
-</file>
-
-<file path=ppt/slides/slide19.xml><?xml version="1.0" encoding="utf-8"?>
-<p:sld xmlns:a="http://schemas.openxmlformats.org/drawingml/2006/main" xmlns:r="http://schemas.openxmlformats.org/officeDocument/2006/relationships" xmlns:mc="http://schemas.openxmlformats.org/markup-compatibility/2006" xmlns:mv="urn:schemas-microsoft-com:mac:vml" xmlns:p="http://schemas.openxmlformats.org/presentationml/2006/main" xmlns:c="http://schemas.openxmlformats.org/drawingml/2006/chart" xmlns:dgm="http://schemas.openxmlformats.org/drawingml/2006/diagram" xmlns:o="urn:schemas-microsoft-com:office:office" xmlns:v="urn:schemas-microsoft-com:vml" xmlns:pvml="urn:schemas-microsoft-com:office:powerpoint" xmlns:com="http://schemas.openxmlformats.org/drawingml/2006/compatibility" xmlns:p14="http://schemas.microsoft.com/office/powerpoint/2010/main" xmlns:p15="http://schemas.microsoft.com/office/powerpoint/2012/main" xmlns:ahyp="http://schemas.microsoft.com/office/drawing/2018/hyperlinkcolor">
-  <p:cSld>
-    <p:spTree>
-      <p:nvGrpSpPr>
-        <p:cNvPr id="178" name="Shape 178"/>
-        <p:cNvGrpSpPr/>
-        <p:nvPr/>
-      </p:nvGrpSpPr>
-      <p:grpSpPr>
-        <a:xfrm>
-          <a:off x="0" y="0"/>
-          <a:ext cx="0" cy="0"/>
-          <a:chOff x="0" y="0"/>
-          <a:chExt cx="0" cy="0"/>
-        </a:xfrm>
-      </p:grpSpPr>
-      <p:sp>
-        <p:nvSpPr>
-          <p:cNvPr id="179" name="Google Shape;179;p31"/>
-          <p:cNvSpPr txBox="1"/>
-          <p:nvPr>
-            <p:ph type="title"/>
-          </p:nvPr>
-        </p:nvSpPr>
-        <p:spPr>
-          <a:xfrm>
-            <a:off x="311700" y="445025"/>
-            <a:ext cx="8520600" cy="572700"/>
-          </a:xfrm>
-          <a:prstGeom prst="rect">
-            <a:avLst/>
-          </a:prstGeom>
-        </p:spPr>
-        <p:txBody>
-          <a:bodyPr anchorCtr="0" anchor="t" bIns="91425" lIns="91425" spcFirstLastPara="1" rIns="91425" wrap="square" tIns="91425">
-            <a:normAutofit fontScale="90000"/>
-          </a:bodyPr>
-          <a:lstStyle/>
-          <a:p>
-            <a:pPr indent="0" lvl="0" marL="0" rtl="0" algn="l">
-              <a:spcBef>
-                <a:spcPts val="0"/>
-              </a:spcBef>
-              <a:spcAft>
-                <a:spcPts val="0"/>
-              </a:spcAft>
-              <a:buNone/>
-            </a:pPr>
-            <a:r>
-              <a:rPr lang="en"/>
-              <a:t>Encoder + NN (Together)</a:t>
-            </a:r>
-            <a:endParaRPr/>
-          </a:p>
-        </p:txBody>
-      </p:sp>
-      <p:pic>
-        <p:nvPicPr>
-          <p:cNvPr id="180" name="Google Shape;180;p31"/>
-          <p:cNvPicPr preferRelativeResize="0"/>
-          <p:nvPr/>
-        </p:nvPicPr>
-        <p:blipFill>
-          <a:blip r:embed="rId3">
-            <a:alphaModFix/>
-          </a:blip>
-          <a:stretch>
-            <a:fillRect/>
-          </a:stretch>
-        </p:blipFill>
-        <p:spPr>
-          <a:xfrm>
-            <a:off x="152400" y="1170125"/>
-            <a:ext cx="8839201" cy="3621055"/>
           </a:xfrm>
           <a:prstGeom prst="rect">
             <a:avLst/>
@@ -12690,6 +13087,99 @@
 </file>
 
 <file path=ppt/slides/slide20.xml><?xml version="1.0" encoding="utf-8"?>
+<p:sld xmlns:a="http://schemas.openxmlformats.org/drawingml/2006/main" xmlns:r="http://schemas.openxmlformats.org/officeDocument/2006/relationships" xmlns:mc="http://schemas.openxmlformats.org/markup-compatibility/2006" xmlns:mv="urn:schemas-microsoft-com:mac:vml" xmlns:p="http://schemas.openxmlformats.org/presentationml/2006/main" xmlns:c="http://schemas.openxmlformats.org/drawingml/2006/chart" xmlns:dgm="http://schemas.openxmlformats.org/drawingml/2006/diagram" xmlns:o="urn:schemas-microsoft-com:office:office" xmlns:v="urn:schemas-microsoft-com:vml" xmlns:pvml="urn:schemas-microsoft-com:office:powerpoint" xmlns:com="http://schemas.openxmlformats.org/drawingml/2006/compatibility" xmlns:p14="http://schemas.microsoft.com/office/powerpoint/2010/main" xmlns:p15="http://schemas.microsoft.com/office/powerpoint/2012/main" xmlns:ahyp="http://schemas.microsoft.com/office/drawing/2018/hyperlinkcolor">
+  <p:cSld>
+    <p:spTree>
+      <p:nvGrpSpPr>
+        <p:cNvPr id="178" name="Shape 178"/>
+        <p:cNvGrpSpPr/>
+        <p:nvPr/>
+      </p:nvGrpSpPr>
+      <p:grpSpPr>
+        <a:xfrm>
+          <a:off x="0" y="0"/>
+          <a:ext cx="0" cy="0"/>
+          <a:chOff x="0" y="0"/>
+          <a:chExt cx="0" cy="0"/>
+        </a:xfrm>
+      </p:grpSpPr>
+      <p:sp>
+        <p:nvSpPr>
+          <p:cNvPr id="179" name="Google Shape;179;p31"/>
+          <p:cNvSpPr txBox="1"/>
+          <p:nvPr>
+            <p:ph type="title"/>
+          </p:nvPr>
+        </p:nvSpPr>
+        <p:spPr>
+          <a:xfrm>
+            <a:off x="311700" y="445025"/>
+            <a:ext cx="8520600" cy="572700"/>
+          </a:xfrm>
+          <a:prstGeom prst="rect">
+            <a:avLst/>
+          </a:prstGeom>
+        </p:spPr>
+        <p:txBody>
+          <a:bodyPr anchorCtr="0" anchor="t" bIns="91425" lIns="91425" spcFirstLastPara="1" rIns="91425" wrap="square" tIns="91425">
+            <a:normAutofit fontScale="90000"/>
+          </a:bodyPr>
+          <a:lstStyle/>
+          <a:p>
+            <a:pPr indent="0" lvl="0" marL="0" rtl="0" algn="l">
+              <a:spcBef>
+                <a:spcPts val="0"/>
+              </a:spcBef>
+              <a:spcAft>
+                <a:spcPts val="0"/>
+              </a:spcAft>
+              <a:buNone/>
+            </a:pPr>
+            <a:r>
+              <a:rPr lang="en"/>
+              <a:t>Encoder + NN (Together)</a:t>
+            </a:r>
+            <a:endParaRPr/>
+          </a:p>
+        </p:txBody>
+      </p:sp>
+      <p:pic>
+        <p:nvPicPr>
+          <p:cNvPr id="180" name="Google Shape;180;p31"/>
+          <p:cNvPicPr preferRelativeResize="0"/>
+          <p:nvPr/>
+        </p:nvPicPr>
+        <p:blipFill>
+          <a:blip r:embed="rId3">
+            <a:alphaModFix/>
+          </a:blip>
+          <a:stretch>
+            <a:fillRect/>
+          </a:stretch>
+        </p:blipFill>
+        <p:spPr>
+          <a:xfrm>
+            <a:off x="152400" y="1170125"/>
+            <a:ext cx="8839201" cy="3621055"/>
+          </a:xfrm>
+          <a:prstGeom prst="rect">
+            <a:avLst/>
+          </a:prstGeom>
+          <a:noFill/>
+          <a:ln>
+            <a:noFill/>
+          </a:ln>
+        </p:spPr>
+      </p:pic>
+    </p:spTree>
+  </p:cSld>
+  <p:clrMapOvr>
+    <a:masterClrMapping/>
+  </p:clrMapOvr>
+</p:sld>
+</file>
+
+<file path=ppt/slides/slide21.xml><?xml version="1.0" encoding="utf-8"?>
 <p:sld xmlns:a="http://schemas.openxmlformats.org/drawingml/2006/main" xmlns:r="http://schemas.openxmlformats.org/officeDocument/2006/relationships" xmlns:mc="http://schemas.openxmlformats.org/markup-compatibility/2006" xmlns:mv="urn:schemas-microsoft-com:mac:vml" xmlns:p="http://schemas.openxmlformats.org/presentationml/2006/main" xmlns:c="http://schemas.openxmlformats.org/drawingml/2006/chart" xmlns:dgm="http://schemas.openxmlformats.org/drawingml/2006/diagram" xmlns:o="urn:schemas-microsoft-com:office:office" xmlns:v="urn:schemas-microsoft-com:vml" xmlns:pvml="urn:schemas-microsoft-com:office:powerpoint" xmlns:com="http://schemas.openxmlformats.org/drawingml/2006/compatibility" xmlns:p14="http://schemas.microsoft.com/office/powerpoint/2010/main" xmlns:p15="http://schemas.microsoft.com/office/powerpoint/2012/main" xmlns:ahyp="http://schemas.microsoft.com/office/drawing/2018/hyperlinkcolor">
   <p:cSld>
     <p:spTree>
@@ -12782,7 +13272,7 @@
 </p:sld>
 </file>
 
-<file path=ppt/slides/slide21.xml><?xml version="1.0" encoding="utf-8"?>
+<file path=ppt/slides/slide22.xml><?xml version="1.0" encoding="utf-8"?>
 <p:sld xmlns:a="http://schemas.openxmlformats.org/drawingml/2006/main" xmlns:r="http://schemas.openxmlformats.org/officeDocument/2006/relationships" xmlns:mc="http://schemas.openxmlformats.org/markup-compatibility/2006" xmlns:mv="urn:schemas-microsoft-com:mac:vml" xmlns:p="http://schemas.openxmlformats.org/presentationml/2006/main" xmlns:c="http://schemas.openxmlformats.org/drawingml/2006/chart" xmlns:dgm="http://schemas.openxmlformats.org/drawingml/2006/diagram" xmlns:o="urn:schemas-microsoft-com:office:office" xmlns:v="urn:schemas-microsoft-com:vml" xmlns:pvml="urn:schemas-microsoft-com:office:powerpoint" xmlns:com="http://schemas.openxmlformats.org/drawingml/2006/compatibility" xmlns:p14="http://schemas.microsoft.com/office/powerpoint/2010/main" xmlns:p15="http://schemas.microsoft.com/office/powerpoint/2012/main" xmlns:ahyp="http://schemas.microsoft.com/office/drawing/2018/hyperlinkcolor">
   <p:cSld>
     <p:spTree>
@@ -12867,389 +13357,6 @@
           </a:ln>
         </p:spPr>
       </p:pic>
-    </p:spTree>
-  </p:cSld>
-  <p:clrMapOvr>
-    <a:masterClrMapping/>
-  </p:clrMapOvr>
-</p:sld>
-</file>
-
-<file path=ppt/slides/slide22.xml><?xml version="1.0" encoding="utf-8"?>
-<p:sld xmlns:a="http://schemas.openxmlformats.org/drawingml/2006/main" xmlns:p="http://schemas.openxmlformats.org/presentationml/2006/main" xmlns:r="http://schemas.openxmlformats.org/officeDocument/2006/relationships">
-  <p:cSld>
-    <p:spTree>
-      <p:nvGrpSpPr>
-        <p:cNvPr id="1" name=""/>
-        <p:cNvGrpSpPr/>
-        <p:nvPr/>
-      </p:nvGrpSpPr>
-      <p:grpSpPr/>
-      <p:sp>
-        <p:nvSpPr>
-          <p:cNvPr id="2" name="Title 1"/>
-          <p:cNvSpPr>
-            <a:spLocks noGrp="1"/>
-          </p:cNvSpPr>
-          <p:nvPr>
-            <p:ph type="title"/>
-          </p:nvPr>
-        </p:nvSpPr>
-        <p:spPr/>
-        <p:txBody>
-          <a:bodyPr/>
-          <a:lstStyle/>
-          <a:p>
-            <a:r>
-              <a:t>Sentiment vs. what happened next</a:t>
-            </a:r>
-          </a:p>
-        </p:txBody>
-      </p:sp>
-      <p:graphicFrame>
-        <p:nvGraphicFramePr>
-          <p:cNvPr id="3" name="Table 2"/>
-          <p:cNvGraphicFramePr>
-            <a:graphicFrameLocks noGrp="1"/>
-          </p:cNvGraphicFramePr>
-          <p:nvPr/>
-        </p:nvGraphicFramePr>
-        <p:xfrm>
-          <a:off x="640080" y="1188720"/>
-          <a:ext cx="7863840" cy="1645919"/>
-        </p:xfrm>
-        <a:graphic>
-          <a:graphicData uri="http://schemas.openxmlformats.org/drawingml/2006/table">
-            <a:tbl>
-              <a:tblPr firstRow="1" bandRow="1">
-                <a:tableStyleId>{5C22544A-7EE6-4342-B048-85BDC9FD1C3A}</a:tableStyleId>
-              </a:tblPr>
-              <a:tblGrid>
-                <a:gridCol w="3108960"/>
-                <a:gridCol w="2377440"/>
-                <a:gridCol w="2377440"/>
-              </a:tblGrid>
-              <a:tr h="274319">
-                <a:tc>
-                  <a:txBody>
-                    <a:bodyPr/>
-                    <a:lstStyle/>
-                    <a:p>
-                      <a:pPr>
-                        <a:defRPr sz="1200" b="1"/>
-                      </a:pPr>
-                      <a:r>
-                        <a:t>LLM sentiment</a:t>
-                      </a:r>
-                    </a:p>
-                  </a:txBody>
-                  <a:tcPr/>
-                </a:tc>
-                <a:tc>
-                  <a:txBody>
-                    <a:bodyPr/>
-                    <a:lstStyle/>
-                    <a:p>
-                      <a:pPr>
-                        <a:defRPr sz="1200" b="1"/>
-                      </a:pPr>
-                      <a:r>
-                        <a:t>next move DOWN</a:t>
-                      </a:r>
-                    </a:p>
-                  </a:txBody>
-                  <a:tcPr/>
-                </a:tc>
-                <a:tc>
-                  <a:txBody>
-                    <a:bodyPr/>
-                    <a:lstStyle/>
-                    <a:p>
-                      <a:pPr>
-                        <a:defRPr sz="1200" b="1"/>
-                      </a:pPr>
-                      <a:r>
-                        <a:t>next move UP</a:t>
-                      </a:r>
-                    </a:p>
-                  </a:txBody>
-                  <a:tcPr/>
-                </a:tc>
-              </a:tr>
-              <a:tr h="274319">
-                <a:tc>
-                  <a:txBody>
-                    <a:bodyPr/>
-                    <a:lstStyle/>
-                    <a:p>
-                      <a:pPr>
-                        <a:defRPr sz="1200" b="0"/>
-                      </a:pPr>
-                      <a:r>
-                        <a:t>Strongly negative</a:t>
-                      </a:r>
-                    </a:p>
-                  </a:txBody>
-                  <a:tcPr/>
-                </a:tc>
-                <a:tc>
-                  <a:txBody>
-                    <a:bodyPr/>
-                    <a:lstStyle/>
-                    <a:p>
-                      <a:pPr>
-                        <a:defRPr sz="1200" b="0"/>
-                      </a:pPr>
-                      <a:r>
-                        <a:t>50.80%</a:t>
-                      </a:r>
-                    </a:p>
-                  </a:txBody>
-                  <a:tcPr/>
-                </a:tc>
-                <a:tc>
-                  <a:txBody>
-                    <a:bodyPr/>
-                    <a:lstStyle/>
-                    <a:p>
-                      <a:pPr>
-                        <a:defRPr sz="1200" b="0"/>
-                      </a:pPr>
-                      <a:r>
-                        <a:t>49.20%</a:t>
-                      </a:r>
-                    </a:p>
-                  </a:txBody>
-                  <a:tcPr/>
-                </a:tc>
-              </a:tr>
-              <a:tr h="274319">
-                <a:tc>
-                  <a:txBody>
-                    <a:bodyPr/>
-                    <a:lstStyle/>
-                    <a:p>
-                      <a:pPr>
-                        <a:defRPr sz="1200" b="0"/>
-                      </a:pPr>
-                      <a:r>
-                        <a:t>Negative</a:t>
-                      </a:r>
-                    </a:p>
-                  </a:txBody>
-                  <a:tcPr/>
-                </a:tc>
-                <a:tc>
-                  <a:txBody>
-                    <a:bodyPr/>
-                    <a:lstStyle/>
-                    <a:p>
-                      <a:pPr>
-                        <a:defRPr sz="1200" b="0"/>
-                      </a:pPr>
-                      <a:r>
-                        <a:t>49.82%</a:t>
-                      </a:r>
-                    </a:p>
-                  </a:txBody>
-                  <a:tcPr/>
-                </a:tc>
-                <a:tc>
-                  <a:txBody>
-                    <a:bodyPr/>
-                    <a:lstStyle/>
-                    <a:p>
-                      <a:pPr>
-                        <a:defRPr sz="1200" b="0"/>
-                      </a:pPr>
-                      <a:r>
-                        <a:t>50.18%</a:t>
-                      </a:r>
-                    </a:p>
-                  </a:txBody>
-                  <a:tcPr/>
-                </a:tc>
-              </a:tr>
-              <a:tr h="274319">
-                <a:tc>
-                  <a:txBody>
-                    <a:bodyPr/>
-                    <a:lstStyle/>
-                    <a:p>
-                      <a:pPr>
-                        <a:defRPr sz="1200" b="0"/>
-                      </a:pPr>
-                      <a:r>
-                        <a:t>Neutral</a:t>
-                      </a:r>
-                    </a:p>
-                  </a:txBody>
-                  <a:tcPr/>
-                </a:tc>
-                <a:tc>
-                  <a:txBody>
-                    <a:bodyPr/>
-                    <a:lstStyle/>
-                    <a:p>
-                      <a:pPr>
-                        <a:defRPr sz="1200" b="0"/>
-                      </a:pPr>
-                      <a:r>
-                        <a:t>51.14%</a:t>
-                      </a:r>
-                    </a:p>
-                  </a:txBody>
-                  <a:tcPr/>
-                </a:tc>
-                <a:tc>
-                  <a:txBody>
-                    <a:bodyPr/>
-                    <a:lstStyle/>
-                    <a:p>
-                      <a:pPr>
-                        <a:defRPr sz="1200" b="0"/>
-                      </a:pPr>
-                      <a:r>
-                        <a:t>48.86%</a:t>
-                      </a:r>
-                    </a:p>
-                  </a:txBody>
-                  <a:tcPr/>
-                </a:tc>
-              </a:tr>
-              <a:tr h="274319">
-                <a:tc>
-                  <a:txBody>
-                    <a:bodyPr/>
-                    <a:lstStyle/>
-                    <a:p>
-                      <a:pPr>
-                        <a:defRPr sz="1200" b="0"/>
-                      </a:pPr>
-                      <a:r>
-                        <a:t>Positive</a:t>
-                      </a:r>
-                    </a:p>
-                  </a:txBody>
-                  <a:tcPr/>
-                </a:tc>
-                <a:tc>
-                  <a:txBody>
-                    <a:bodyPr/>
-                    <a:lstStyle/>
-                    <a:p>
-                      <a:pPr>
-                        <a:defRPr sz="1200" b="0"/>
-                      </a:pPr>
-                      <a:r>
-                        <a:t>49.76%</a:t>
-                      </a:r>
-                    </a:p>
-                  </a:txBody>
-                  <a:tcPr/>
-                </a:tc>
-                <a:tc>
-                  <a:txBody>
-                    <a:bodyPr/>
-                    <a:lstStyle/>
-                    <a:p>
-                      <a:pPr>
-                        <a:defRPr sz="1200" b="0"/>
-                      </a:pPr>
-                      <a:r>
-                        <a:t>50.24%</a:t>
-                      </a:r>
-                    </a:p>
-                  </a:txBody>
-                  <a:tcPr/>
-                </a:tc>
-              </a:tr>
-              <a:tr h="274324">
-                <a:tc>
-                  <a:txBody>
-                    <a:bodyPr/>
-                    <a:lstStyle/>
-                    <a:p>
-                      <a:pPr>
-                        <a:defRPr sz="1200" b="0"/>
-                      </a:pPr>
-                      <a:r>
-                        <a:t>Strongly positive</a:t>
-                      </a:r>
-                    </a:p>
-                  </a:txBody>
-                  <a:tcPr/>
-                </a:tc>
-                <a:tc>
-                  <a:txBody>
-                    <a:bodyPr/>
-                    <a:lstStyle/>
-                    <a:p>
-                      <a:pPr>
-                        <a:defRPr sz="1200" b="0"/>
-                      </a:pPr>
-                      <a:r>
-                        <a:t>50.14%</a:t>
-                      </a:r>
-                    </a:p>
-                  </a:txBody>
-                  <a:tcPr/>
-                </a:tc>
-                <a:tc>
-                  <a:txBody>
-                    <a:bodyPr/>
-                    <a:lstStyle/>
-                    <a:p>
-                      <a:pPr>
-                        <a:defRPr sz="1200" b="0"/>
-                      </a:pPr>
-                      <a:r>
-                        <a:t>49.86%</a:t>
-                      </a:r>
-                    </a:p>
-                  </a:txBody>
-                  <a:tcPr/>
-                </a:tc>
-              </a:tr>
-            </a:tbl>
-          </a:graphicData>
-        </a:graphic>
-      </p:graphicFrame>
-      <p:sp>
-        <p:nvSpPr>
-          <p:cNvPr id="4" name="TextBox 3"/>
-          <p:cNvSpPr txBox="1"/>
-          <p:nvPr/>
-        </p:nvSpPr>
-        <p:spPr>
-          <a:xfrm>
-            <a:off x="310896" y="4023360"/>
-            <a:ext cx="8522208" cy="548640"/>
-          </a:xfrm>
-          <a:prstGeom prst="rect">
-            <a:avLst/>
-          </a:prstGeom>
-          <a:noFill/>
-        </p:spPr>
-        <p:txBody>
-          <a:bodyPr wrap="square">
-            <a:spAutoFit/>
-          </a:bodyPr>
-          <a:lstStyle/>
-          <a:p>
-            <a:pPr algn="ctr">
-              <a:defRPr sz="1400" b="1">
-                <a:solidFill>
-                  <a:srgbClr val="C0392B"/>
-                </a:solidFill>
-              </a:defRPr>
-            </a:pPr>
-            <a:r>
-              <a:t>Every sentiment class is a coin flip — a property of the data, not of any model.</a:t>
-            </a:r>
-          </a:p>
-        </p:txBody>
-      </p:sp>
     </p:spTree>
   </p:cSld>
   <p:clrMapOvr>
@@ -15444,6 +15551,104 @@
             </a:pPr>
             <a:r>
               <a:t>Substantially more data</a:t>
+            </a:r>
+          </a:p>
+        </p:txBody>
+      </p:sp>
+    </p:spTree>
+  </p:cSld>
+  <p:clrMapOvr>
+    <a:masterClrMapping/>
+  </p:clrMapOvr>
+</p:sld>
+</file>
+
+<file path=ppt/slides/slide34.xml><?xml version="1.0" encoding="utf-8"?>
+<p:sld xmlns:a="http://schemas.openxmlformats.org/drawingml/2006/main" xmlns:p="http://schemas.openxmlformats.org/presentationml/2006/main" xmlns:r="http://schemas.openxmlformats.org/officeDocument/2006/relationships">
+  <p:cSld>
+    <p:spTree>
+      <p:nvGrpSpPr>
+        <p:cNvPr id="1" name=""/>
+        <p:cNvGrpSpPr/>
+        <p:nvPr/>
+      </p:nvGrpSpPr>
+      <p:grpSpPr/>
+      <p:sp>
+        <p:nvSpPr>
+          <p:cNvPr id="2" name="Title 1"/>
+          <p:cNvSpPr>
+            <a:spLocks noGrp="1"/>
+          </p:cNvSpPr>
+          <p:nvPr>
+            <p:ph type="title"/>
+          </p:nvPr>
+        </p:nvSpPr>
+        <p:spPr/>
+        <p:txBody>
+          <a:bodyPr/>
+          <a:lstStyle/>
+          <a:p>
+            <a:r>
+              <a:t>Is 90 minutes even the right horizon?</a:t>
+            </a:r>
+          </a:p>
+        </p:txBody>
+      </p:sp>
+      <p:pic>
+        <p:nvPicPr>
+          <p:cNvPr id="3" name="Picture 2" descr="15-sentiment-vs-gain-heatmap.png"/>
+          <p:cNvPicPr>
+            <a:picLocks noChangeAspect="1"/>
+          </p:cNvPicPr>
+          <p:nvPr/>
+        </p:nvPicPr>
+        <p:blipFill>
+          <a:blip r:embed="rId2"/>
+          <a:stretch>
+            <a:fillRect/>
+          </a:stretch>
+        </p:blipFill>
+        <p:spPr>
+          <a:xfrm>
+            <a:off x="2979198" y="1051560"/>
+            <a:ext cx="3185604" cy="3177540"/>
+          </a:xfrm>
+          <a:prstGeom prst="rect">
+            <a:avLst/>
+          </a:prstGeom>
+        </p:spPr>
+      </p:pic>
+      <p:sp>
+        <p:nvSpPr>
+          <p:cNvPr id="4" name="TextBox 3"/>
+          <p:cNvSpPr txBox="1"/>
+          <p:nvPr/>
+        </p:nvSpPr>
+        <p:spPr>
+          <a:xfrm>
+            <a:off x="310896" y="4366260"/>
+            <a:ext cx="8522208" cy="548640"/>
+          </a:xfrm>
+          <a:prstGeom prst="rect">
+            <a:avLst/>
+          </a:prstGeom>
+          <a:noFill/>
+        </p:spPr>
+        <p:txBody>
+          <a:bodyPr wrap="square">
+            <a:spAutoFit/>
+          </a:bodyPr>
+          <a:lstStyle/>
+          <a:p>
+            <a:pPr algn="ctr">
+              <a:defRPr sz="1400" b="1">
+                <a:solidFill>
+                  <a:srgbClr val="C0392B"/>
+                </a:solidFill>
+              </a:defRPr>
+            </a:pPr>
+            <a:r>
+              <a:t>52% of articles move less than ±0.5%.  Of the rest: 50.2% down / 49.8% up.</a:t>
             </a:r>
           </a:p>
         </p:txBody>

</xml_diff>